<commit_message>
feat(03-spe): agrega HVM completo, Account Plan FY27 y artefactos S&PE
- Nuevos specialists: Informix SPL, Oracle Forms PL-SQL, SQL Server T-SQL, 7R Assessment, Batch Architecture, Reverse Engineering
- Carpetas de cliente: BanCoppel (BCOPCore + knowledge-base) y BBVA + Banamex mainframe
- Fases HVM renombradas: Fase 2/3/6/8 (externo) → Regulatory, Test & Equivalence, Data Migration, Decommission
- Artefactos nuevos: catálogo patrones COBOL→SpringBoot, KB retos mainframe banca, metodología Gemelo Cognitivo
- Account Plan FY27 S&PE completo (CLAUDE.md, revenue, TAM, backlog, competitive, practice-summary + fuentes xlsx/pptx)
- MDP: Account Planning FY27 AI-ready Data
- spec-account-onboarding-l2 (md + docx)
- .gitignore: excluye .claude/worktrees/ (repos embebidos de Claude Code)
- CLAUDE.md actualizados: HVM, Application Modernization, Mainframe Modernization, Specialist Reverse Engineering

Co-Authored-By: Claude Sonnet 4.6 <noreply@anthropic.com>
</commit_message>
<xml_diff>
--- a/03 - Software & Platform Engineering/Estrategia_Software_Platform_Engineering_v1.pptx
+++ b/03 - Software & Platform Engineering/Estrategia_Software_Platform_Engineering_v1.pptx
@@ -134,20 +134,12 @@
 </p:presentation>
 </file>
 
-<file path=ppt/revisionInfo.xml><?xml version="1.0" encoding="utf-8"?>
-<p1510:revInfo xmlns:a="http://schemas.openxmlformats.org/drawingml/2006/main" xmlns:r="http://schemas.openxmlformats.org/officeDocument/2006/relationships" xmlns:p1510="http://schemas.microsoft.com/office/powerpoint/2015/10/main">
-  <p1510:revLst>
-    <p1510:client id="{A171E5EB-D6B8-4124-9304-EAE702C91CDD}" v="2" dt="2026-06-02T12:21:34.322"/>
-  </p1510:revLst>
-</p1510:revInfo>
-</file>
-
 <file path=ppt/changesInfos/changesInfo1.xml><?xml version="1.0" encoding="utf-8"?>
 <pc:chgInfo xmlns:a="http://schemas.openxmlformats.org/drawingml/2006/main" xmlns:r="http://schemas.openxmlformats.org/officeDocument/2006/relationships" xmlns:ac="http://schemas.microsoft.com/office/drawing/2013/main/command" xmlns:pc="http://schemas.microsoft.com/office/powerpoint/2013/main/command">
   <pc:docChgLst>
     <pc:chgData name="Gallegos, Alejandro" userId="7a0a55fa-7938-462f-86a3-ee9e344a5cc2" providerId="ADAL" clId="{78F901EC-5879-4A32-9A3E-0F0D8701D1BA}"/>
     <pc:docChg chg="undo custSel delSld modSld sldOrd">
-      <pc:chgData name="Gallegos, Alejandro" userId="7a0a55fa-7938-462f-86a3-ee9e344a5cc2" providerId="ADAL" clId="{78F901EC-5879-4A32-9A3E-0F0D8701D1BA}" dt="2026-06-02T16:07:15.675" v="1148" actId="478"/>
+      <pc:chgData name="Gallegos, Alejandro" userId="7a0a55fa-7938-462f-86a3-ee9e344a5cc2" providerId="ADAL" clId="{78F901EC-5879-4A32-9A3E-0F0D8701D1BA}" dt="2026-06-12T16:40:17.583" v="1249" actId="14100"/>
       <pc:docMkLst>
         <pc:docMk/>
       </pc:docMkLst>
@@ -292,14 +284,6 @@
           <pc:docMk/>
           <pc:sldMk cId="0" sldId="257"/>
         </pc:sldMkLst>
-        <pc:spChg chg="del mod">
-          <ac:chgData name="Gallegos, Alejandro" userId="7a0a55fa-7938-462f-86a3-ee9e344a5cc2" providerId="ADAL" clId="{78F901EC-5879-4A32-9A3E-0F0D8701D1BA}" dt="2026-06-02T01:43:23.115" v="286" actId="478"/>
-          <ac:spMkLst>
-            <pc:docMk/>
-            <pc:sldMk cId="0" sldId="257"/>
-            <ac:spMk id="2" creationId="{00000000-0000-0000-0000-000000000000}"/>
-          </ac:spMkLst>
-        </pc:spChg>
         <pc:spChg chg="mod">
           <ac:chgData name="Gallegos, Alejandro" userId="7a0a55fa-7938-462f-86a3-ee9e344a5cc2" providerId="ADAL" clId="{78F901EC-5879-4A32-9A3E-0F0D8701D1BA}" dt="2026-06-02T01:43:09.726" v="283" actId="20577"/>
           <ac:spMkLst>
@@ -395,14 +379,6 @@
           <pc:docMk/>
           <pc:sldMk cId="0" sldId="258"/>
         </pc:sldMkLst>
-        <pc:spChg chg="del">
-          <ac:chgData name="Gallegos, Alejandro" userId="7a0a55fa-7938-462f-86a3-ee9e344a5cc2" providerId="ADAL" clId="{78F901EC-5879-4A32-9A3E-0F0D8701D1BA}" dt="2026-06-02T01:54:00.111" v="319" actId="478"/>
-          <ac:spMkLst>
-            <pc:docMk/>
-            <pc:sldMk cId="0" sldId="258"/>
-            <ac:spMk id="2" creationId="{00000000-0000-0000-0000-000000000000}"/>
-          </ac:spMkLst>
-        </pc:spChg>
         <pc:spChg chg="mod">
           <ac:chgData name="Gallegos, Alejandro" userId="7a0a55fa-7938-462f-86a3-ee9e344a5cc2" providerId="ADAL" clId="{78F901EC-5879-4A32-9A3E-0F0D8701D1BA}" dt="2026-06-02T02:01:44.939" v="330" actId="20577"/>
           <ac:spMkLst>
@@ -420,27 +396,12 @@
           </ac:spMkLst>
         </pc:spChg>
       </pc:sldChg>
-      <pc:sldChg chg="del">
-        <pc:chgData name="Gallegos, Alejandro" userId="7a0a55fa-7938-462f-86a3-ee9e344a5cc2" providerId="ADAL" clId="{78F901EC-5879-4A32-9A3E-0F0D8701D1BA}" dt="2026-06-02T01:48:13.765" v="305" actId="47"/>
-        <pc:sldMkLst>
-          <pc:docMk/>
-          <pc:sldMk cId="0" sldId="259"/>
-        </pc:sldMkLst>
-      </pc:sldChg>
       <pc:sldChg chg="delSp modSp mod">
         <pc:chgData name="Gallegos, Alejandro" userId="7a0a55fa-7938-462f-86a3-ee9e344a5cc2" providerId="ADAL" clId="{78F901EC-5879-4A32-9A3E-0F0D8701D1BA}" dt="2026-06-02T01:55:45.792" v="321" actId="20577"/>
         <pc:sldMkLst>
           <pc:docMk/>
           <pc:sldMk cId="0" sldId="260"/>
         </pc:sldMkLst>
-        <pc:spChg chg="del mod">
-          <ac:chgData name="Gallegos, Alejandro" userId="7a0a55fa-7938-462f-86a3-ee9e344a5cc2" providerId="ADAL" clId="{78F901EC-5879-4A32-9A3E-0F0D8701D1BA}" dt="2026-06-02T01:53:55.358" v="318" actId="478"/>
-          <ac:spMkLst>
-            <pc:docMk/>
-            <pc:sldMk cId="0" sldId="260"/>
-            <ac:spMk id="2" creationId="{00000000-0000-0000-0000-000000000000}"/>
-          </ac:spMkLst>
-        </pc:spChg>
         <pc:spChg chg="mod">
           <ac:chgData name="Gallegos, Alejandro" userId="7a0a55fa-7938-462f-86a3-ee9e344a5cc2" providerId="ADAL" clId="{78F901EC-5879-4A32-9A3E-0F0D8701D1BA}" dt="2026-06-02T01:52:29.213" v="314" actId="20577"/>
           <ac:spMkLst>
@@ -466,27 +427,12 @@
           </ac:spMkLst>
         </pc:spChg>
       </pc:sldChg>
-      <pc:sldChg chg="del">
-        <pc:chgData name="Gallegos, Alejandro" userId="7a0a55fa-7938-462f-86a3-ee9e344a5cc2" providerId="ADAL" clId="{78F901EC-5879-4A32-9A3E-0F0D8701D1BA}" dt="2026-06-02T02:01:49.065" v="331" actId="47"/>
-        <pc:sldMkLst>
-          <pc:docMk/>
-          <pc:sldMk cId="0" sldId="264"/>
-        </pc:sldMkLst>
-      </pc:sldChg>
       <pc:sldChg chg="delSp modSp mod">
         <pc:chgData name="Gallegos, Alejandro" userId="7a0a55fa-7938-462f-86a3-ee9e344a5cc2" providerId="ADAL" clId="{78F901EC-5879-4A32-9A3E-0F0D8701D1BA}" dt="2026-06-02T02:02:16.312" v="335" actId="1076"/>
         <pc:sldMkLst>
           <pc:docMk/>
           <pc:sldMk cId="0" sldId="265"/>
         </pc:sldMkLst>
-        <pc:spChg chg="del mod">
-          <ac:chgData name="Gallegos, Alejandro" userId="7a0a55fa-7938-462f-86a3-ee9e344a5cc2" providerId="ADAL" clId="{78F901EC-5879-4A32-9A3E-0F0D8701D1BA}" dt="2026-06-02T02:02:03.417" v="333" actId="478"/>
-          <ac:spMkLst>
-            <pc:docMk/>
-            <pc:sldMk cId="0" sldId="265"/>
-            <ac:spMk id="2" creationId="{00000000-0000-0000-0000-000000000000}"/>
-          </ac:spMkLst>
-        </pc:spChg>
         <pc:spChg chg="mod">
           <ac:chgData name="Gallegos, Alejandro" userId="7a0a55fa-7938-462f-86a3-ee9e344a5cc2" providerId="ADAL" clId="{78F901EC-5879-4A32-9A3E-0F0D8701D1BA}" dt="2026-06-02T02:02:09.906" v="334" actId="1076"/>
           <ac:spMkLst>
@@ -560,174 +506,36 @@
           </ac:spMkLst>
         </pc:spChg>
       </pc:sldChg>
-      <pc:sldChg chg="del">
-        <pc:chgData name="Gallegos, Alejandro" userId="7a0a55fa-7938-462f-86a3-ee9e344a5cc2" providerId="ADAL" clId="{78F901EC-5879-4A32-9A3E-0F0D8701D1BA}" dt="2026-06-02T02:02:33.932" v="336" actId="47"/>
-        <pc:sldMkLst>
-          <pc:docMk/>
-          <pc:sldMk cId="0" sldId="266"/>
-        </pc:sldMkLst>
-      </pc:sldChg>
-      <pc:sldChg chg="del">
-        <pc:chgData name="Gallegos, Alejandro" userId="7a0a55fa-7938-462f-86a3-ee9e344a5cc2" providerId="ADAL" clId="{78F901EC-5879-4A32-9A3E-0F0D8701D1BA}" dt="2026-06-02T02:03:10.277" v="337" actId="47"/>
-        <pc:sldMkLst>
-          <pc:docMk/>
-          <pc:sldMk cId="0" sldId="267"/>
-        </pc:sldMkLst>
-      </pc:sldChg>
-      <pc:sldChg chg="del">
-        <pc:chgData name="Gallegos, Alejandro" userId="7a0a55fa-7938-462f-86a3-ee9e344a5cc2" providerId="ADAL" clId="{78F901EC-5879-4A32-9A3E-0F0D8701D1BA}" dt="2026-06-02T12:46:13.346" v="1146" actId="47"/>
-        <pc:sldMkLst>
-          <pc:docMk/>
-          <pc:sldMk cId="0" sldId="268"/>
-        </pc:sldMkLst>
-      </pc:sldChg>
       <pc:sldChg chg="addSp delSp modSp mod ord">
-        <pc:chgData name="Gallegos, Alejandro" userId="7a0a55fa-7938-462f-86a3-ee9e344a5cc2" providerId="ADAL" clId="{78F901EC-5879-4A32-9A3E-0F0D8701D1BA}" dt="2026-06-02T16:07:15.675" v="1148" actId="478"/>
+        <pc:chgData name="Gallegos, Alejandro" userId="7a0a55fa-7938-462f-86a3-ee9e344a5cc2" providerId="ADAL" clId="{78F901EC-5879-4A32-9A3E-0F0D8701D1BA}" dt="2026-06-12T16:40:17.583" v="1249" actId="14100"/>
         <pc:sldMkLst>
           <pc:docMk/>
           <pc:sldMk cId="0" sldId="269"/>
         </pc:sldMkLst>
-        <pc:spChg chg="del mod">
-          <ac:chgData name="Gallegos, Alejandro" userId="7a0a55fa-7938-462f-86a3-ee9e344a5cc2" providerId="ADAL" clId="{78F901EC-5879-4A32-9A3E-0F0D8701D1BA}" dt="2026-06-02T12:12:09.566" v="353" actId="478"/>
-          <ac:spMkLst>
-            <pc:docMk/>
-            <pc:sldMk cId="0" sldId="269"/>
-            <ac:spMk id="2" creationId="{00000000-0000-0000-0000-000000000000}"/>
-          </ac:spMkLst>
-        </pc:spChg>
         <pc:spChg chg="mod">
-          <ac:chgData name="Gallegos, Alejandro" userId="7a0a55fa-7938-462f-86a3-ee9e344a5cc2" providerId="ADAL" clId="{78F901EC-5879-4A32-9A3E-0F0D8701D1BA}" dt="2026-06-02T12:11:00.383" v="348" actId="20577"/>
+          <ac:chgData name="Gallegos, Alejandro" userId="7a0a55fa-7938-462f-86a3-ee9e344a5cc2" providerId="ADAL" clId="{78F901EC-5879-4A32-9A3E-0F0D8701D1BA}" dt="2026-06-12T16:39:45.480" v="1212" actId="20577"/>
           <ac:spMkLst>
             <pc:docMk/>
             <pc:sldMk cId="0" sldId="269"/>
             <ac:spMk id="5" creationId="{00000000-0000-0000-0000-000000000000}"/>
           </ac:spMkLst>
         </pc:spChg>
-        <pc:spChg chg="mod">
-          <ac:chgData name="Gallegos, Alejandro" userId="7a0a55fa-7938-462f-86a3-ee9e344a5cc2" providerId="ADAL" clId="{78F901EC-5879-4A32-9A3E-0F0D8701D1BA}" dt="2026-06-02T12:11:04.095" v="349" actId="1076"/>
+        <pc:spChg chg="del mod">
+          <ac:chgData name="Gallegos, Alejandro" userId="7a0a55fa-7938-462f-86a3-ee9e344a5cc2" providerId="ADAL" clId="{78F901EC-5879-4A32-9A3E-0F0D8701D1BA}" dt="2026-06-12T16:39:15.052" v="1164" actId="478"/>
           <ac:spMkLst>
             <pc:docMk/>
             <pc:sldMk cId="0" sldId="269"/>
             <ac:spMk id="6" creationId="{00000000-0000-0000-0000-000000000000}"/>
           </ac:spMkLst>
         </pc:spChg>
-        <pc:spChg chg="del mod">
-          <ac:chgData name="Gallegos, Alejandro" userId="7a0a55fa-7938-462f-86a3-ee9e344a5cc2" providerId="ADAL" clId="{78F901EC-5879-4A32-9A3E-0F0D8701D1BA}" dt="2026-06-02T16:07:06.218" v="1147" actId="478"/>
-          <ac:spMkLst>
-            <pc:docMk/>
-            <pc:sldMk cId="0" sldId="269"/>
-            <ac:spMk id="7" creationId="{00000000-0000-0000-0000-000000000000}"/>
-          </ac:spMkLst>
-        </pc:spChg>
-        <pc:spChg chg="del mod">
-          <ac:chgData name="Gallegos, Alejandro" userId="7a0a55fa-7938-462f-86a3-ee9e344a5cc2" providerId="ADAL" clId="{78F901EC-5879-4A32-9A3E-0F0D8701D1BA}" dt="2026-06-02T16:07:15.675" v="1148" actId="478"/>
-          <ac:spMkLst>
-            <pc:docMk/>
-            <pc:sldMk cId="0" sldId="269"/>
-            <ac:spMk id="8" creationId="{00000000-0000-0000-0000-000000000000}"/>
-          </ac:spMkLst>
-        </pc:spChg>
-        <pc:spChg chg="del mod">
-          <ac:chgData name="Gallegos, Alejandro" userId="7a0a55fa-7938-462f-86a3-ee9e344a5cc2" providerId="ADAL" clId="{78F901EC-5879-4A32-9A3E-0F0D8701D1BA}" dt="2026-06-02T16:07:15.675" v="1148" actId="478"/>
-          <ac:spMkLst>
-            <pc:docMk/>
-            <pc:sldMk cId="0" sldId="269"/>
-            <ac:spMk id="9" creationId="{00000000-0000-0000-0000-000000000000}"/>
-          </ac:spMkLst>
-        </pc:spChg>
-        <pc:spChg chg="del mod">
-          <ac:chgData name="Gallegos, Alejandro" userId="7a0a55fa-7938-462f-86a3-ee9e344a5cc2" providerId="ADAL" clId="{78F901EC-5879-4A32-9A3E-0F0D8701D1BA}" dt="2026-06-02T16:07:15.675" v="1148" actId="478"/>
-          <ac:spMkLst>
-            <pc:docMk/>
-            <pc:sldMk cId="0" sldId="269"/>
-            <ac:spMk id="12" creationId="{00000000-0000-0000-0000-000000000000}"/>
-          </ac:spMkLst>
-        </pc:spChg>
-        <pc:spChg chg="del mod">
-          <ac:chgData name="Gallegos, Alejandro" userId="7a0a55fa-7938-462f-86a3-ee9e344a5cc2" providerId="ADAL" clId="{78F901EC-5879-4A32-9A3E-0F0D8701D1BA}" dt="2026-06-02T16:07:15.675" v="1148" actId="478"/>
-          <ac:spMkLst>
-            <pc:docMk/>
-            <pc:sldMk cId="0" sldId="269"/>
-            <ac:spMk id="16" creationId="{00000000-0000-0000-0000-000000000000}"/>
-          </ac:spMkLst>
-        </pc:spChg>
-        <pc:spChg chg="del mod">
-          <ac:chgData name="Gallegos, Alejandro" userId="7a0a55fa-7938-462f-86a3-ee9e344a5cc2" providerId="ADAL" clId="{78F901EC-5879-4A32-9A3E-0F0D8701D1BA}" dt="2026-06-02T16:07:15.675" v="1148" actId="478"/>
-          <ac:spMkLst>
-            <pc:docMk/>
-            <pc:sldMk cId="0" sldId="269"/>
-            <ac:spMk id="26" creationId="{00000000-0000-0000-0000-000000000000}"/>
-          </ac:spMkLst>
-        </pc:spChg>
-        <pc:spChg chg="del mod">
-          <ac:chgData name="Gallegos, Alejandro" userId="7a0a55fa-7938-462f-86a3-ee9e344a5cc2" providerId="ADAL" clId="{78F901EC-5879-4A32-9A3E-0F0D8701D1BA}" dt="2026-06-02T16:07:15.675" v="1148" actId="478"/>
-          <ac:spMkLst>
-            <pc:docMk/>
-            <pc:sldMk cId="0" sldId="269"/>
-            <ac:spMk id="27" creationId="{00000000-0000-0000-0000-000000000000}"/>
-          </ac:spMkLst>
-        </pc:spChg>
-        <pc:spChg chg="del mod">
-          <ac:chgData name="Gallegos, Alejandro" userId="7a0a55fa-7938-462f-86a3-ee9e344a5cc2" providerId="ADAL" clId="{78F901EC-5879-4A32-9A3E-0F0D8701D1BA}" dt="2026-06-02T16:07:15.675" v="1148" actId="478"/>
-          <ac:spMkLst>
-            <pc:docMk/>
-            <pc:sldMk cId="0" sldId="269"/>
-            <ac:spMk id="28" creationId="{00000000-0000-0000-0000-000000000000}"/>
-          </ac:spMkLst>
-        </pc:spChg>
-        <pc:spChg chg="del mod">
-          <ac:chgData name="Gallegos, Alejandro" userId="7a0a55fa-7938-462f-86a3-ee9e344a5cc2" providerId="ADAL" clId="{78F901EC-5879-4A32-9A3E-0F0D8701D1BA}" dt="2026-06-02T16:07:15.675" v="1148" actId="478"/>
-          <ac:spMkLst>
-            <pc:docMk/>
-            <pc:sldMk cId="0" sldId="269"/>
-            <ac:spMk id="29" creationId="{00000000-0000-0000-0000-000000000000}"/>
-          </ac:spMkLst>
-        </pc:spChg>
-        <pc:spChg chg="del mod">
-          <ac:chgData name="Gallegos, Alejandro" userId="7a0a55fa-7938-462f-86a3-ee9e344a5cc2" providerId="ADAL" clId="{78F901EC-5879-4A32-9A3E-0F0D8701D1BA}" dt="2026-06-02T16:07:15.675" v="1148" actId="478"/>
-          <ac:spMkLst>
-            <pc:docMk/>
-            <pc:sldMk cId="0" sldId="269"/>
-            <ac:spMk id="31" creationId="{00000000-0000-0000-0000-000000000000}"/>
-          </ac:spMkLst>
-        </pc:spChg>
-        <pc:spChg chg="del mod">
-          <ac:chgData name="Gallegos, Alejandro" userId="7a0a55fa-7938-462f-86a3-ee9e344a5cc2" providerId="ADAL" clId="{78F901EC-5879-4A32-9A3E-0F0D8701D1BA}" dt="2026-06-02T16:07:15.675" v="1148" actId="478"/>
-          <ac:spMkLst>
-            <pc:docMk/>
-            <pc:sldMk cId="0" sldId="269"/>
-            <ac:spMk id="32" creationId="{00000000-0000-0000-0000-000000000000}"/>
-          </ac:spMkLst>
-        </pc:spChg>
         <pc:graphicFrameChg chg="add mod modGraphic">
-          <ac:chgData name="Gallegos, Alejandro" userId="7a0a55fa-7938-462f-86a3-ee9e344a5cc2" providerId="ADAL" clId="{78F901EC-5879-4A32-9A3E-0F0D8701D1BA}" dt="2026-06-02T12:45:01.649" v="1140" actId="20577"/>
+          <ac:chgData name="Gallegos, Alejandro" userId="7a0a55fa-7938-462f-86a3-ee9e344a5cc2" providerId="ADAL" clId="{78F901EC-5879-4A32-9A3E-0F0D8701D1BA}" dt="2026-06-12T16:40:17.583" v="1249" actId="14100"/>
           <ac:graphicFrameMkLst>
             <pc:docMk/>
             <pc:sldMk cId="0" sldId="269"/>
             <ac:graphicFrameMk id="37" creationId="{51BA6958-EF1B-23DF-5992-5C4F3583C7BB}"/>
           </ac:graphicFrameMkLst>
         </pc:graphicFrameChg>
-      </pc:sldChg>
-      <pc:sldChg chg="del">
-        <pc:chgData name="Gallegos, Alejandro" userId="7a0a55fa-7938-462f-86a3-ee9e344a5cc2" providerId="ADAL" clId="{78F901EC-5879-4A32-9A3E-0F0D8701D1BA}" dt="2026-06-02T12:11:27.069" v="350" actId="47"/>
-        <pc:sldMkLst>
-          <pc:docMk/>
-          <pc:sldMk cId="0" sldId="270"/>
-        </pc:sldMkLst>
-      </pc:sldChg>
-      <pc:sldChg chg="del">
-        <pc:chgData name="Gallegos, Alejandro" userId="7a0a55fa-7938-462f-86a3-ee9e344a5cc2" providerId="ADAL" clId="{78F901EC-5879-4A32-9A3E-0F0D8701D1BA}" dt="2026-06-02T12:11:32.078" v="351" actId="47"/>
-        <pc:sldMkLst>
-          <pc:docMk/>
-          <pc:sldMk cId="0" sldId="271"/>
-        </pc:sldMkLst>
-      </pc:sldChg>
-      <pc:sldChg chg="del">
-        <pc:chgData name="Gallegos, Alejandro" userId="7a0a55fa-7938-462f-86a3-ee9e344a5cc2" providerId="ADAL" clId="{78F901EC-5879-4A32-9A3E-0F0D8701D1BA}" dt="2026-06-02T12:46:04.384" v="1145" actId="47"/>
-        <pc:sldMkLst>
-          <pc:docMk/>
-          <pc:sldMk cId="0" sldId="273"/>
-        </pc:sldMkLst>
       </pc:sldChg>
     </pc:docChg>
   </pc:docChgLst>
@@ -913,7 +721,7 @@
           <a:p>
             <a:fld id="{5BCAD085-E8A6-8845-BD4E-CB4CCA059FC4}" type="datetimeFigureOut">
               <a:rPr lang="en-US" smtClean="0"/>
-              <a:t>6/2/2026</a:t>
+              <a:t>6/12/2026</a:t>
             </a:fld>
             <a:endParaRPr lang="en-US"/>
           </a:p>
@@ -1081,7 +889,7 @@
           <a:p>
             <a:fld id="{5BCAD085-E8A6-8845-BD4E-CB4CCA059FC4}" type="datetimeFigureOut">
               <a:rPr lang="en-US" smtClean="0"/>
-              <a:t>6/2/2026</a:t>
+              <a:t>6/12/2026</a:t>
             </a:fld>
             <a:endParaRPr lang="en-US"/>
           </a:p>
@@ -1259,7 +1067,7 @@
           <a:p>
             <a:fld id="{5BCAD085-E8A6-8845-BD4E-CB4CCA059FC4}" type="datetimeFigureOut">
               <a:rPr lang="en-US" smtClean="0"/>
-              <a:t>6/2/2026</a:t>
+              <a:t>6/12/2026</a:t>
             </a:fld>
             <a:endParaRPr lang="en-US"/>
           </a:p>
@@ -1427,7 +1235,7 @@
           <a:p>
             <a:fld id="{5BCAD085-E8A6-8845-BD4E-CB4CCA059FC4}" type="datetimeFigureOut">
               <a:rPr lang="en-US" smtClean="0"/>
-              <a:t>6/2/2026</a:t>
+              <a:t>6/12/2026</a:t>
             </a:fld>
             <a:endParaRPr lang="en-US"/>
           </a:p>
@@ -1672,7 +1480,7 @@
           <a:p>
             <a:fld id="{5BCAD085-E8A6-8845-BD4E-CB4CCA059FC4}" type="datetimeFigureOut">
               <a:rPr lang="en-US" smtClean="0"/>
-              <a:t>6/2/2026</a:t>
+              <a:t>6/12/2026</a:t>
             </a:fld>
             <a:endParaRPr lang="en-US"/>
           </a:p>
@@ -1957,7 +1765,7 @@
           <a:p>
             <a:fld id="{5BCAD085-E8A6-8845-BD4E-CB4CCA059FC4}" type="datetimeFigureOut">
               <a:rPr lang="en-US" smtClean="0"/>
-              <a:t>6/2/2026</a:t>
+              <a:t>6/12/2026</a:t>
             </a:fld>
             <a:endParaRPr lang="en-US"/>
           </a:p>
@@ -2376,7 +2184,7 @@
           <a:p>
             <a:fld id="{5BCAD085-E8A6-8845-BD4E-CB4CCA059FC4}" type="datetimeFigureOut">
               <a:rPr lang="en-US" smtClean="0"/>
-              <a:t>6/2/2026</a:t>
+              <a:t>6/12/2026</a:t>
             </a:fld>
             <a:endParaRPr lang="en-US"/>
           </a:p>
@@ -2493,7 +2301,7 @@
           <a:p>
             <a:fld id="{5BCAD085-E8A6-8845-BD4E-CB4CCA059FC4}" type="datetimeFigureOut">
               <a:rPr lang="en-US" smtClean="0"/>
-              <a:t>6/2/2026</a:t>
+              <a:t>6/12/2026</a:t>
             </a:fld>
             <a:endParaRPr lang="en-US"/>
           </a:p>
@@ -2588,7 +2396,7 @@
           <a:p>
             <a:fld id="{5BCAD085-E8A6-8845-BD4E-CB4CCA059FC4}" type="datetimeFigureOut">
               <a:rPr lang="en-US" smtClean="0"/>
-              <a:t>6/2/2026</a:t>
+              <a:t>6/12/2026</a:t>
             </a:fld>
             <a:endParaRPr lang="en-US"/>
           </a:p>
@@ -2863,7 +2671,7 @@
           <a:p>
             <a:fld id="{5BCAD085-E8A6-8845-BD4E-CB4CCA059FC4}" type="datetimeFigureOut">
               <a:rPr lang="en-US" smtClean="0"/>
-              <a:t>6/2/2026</a:t>
+              <a:t>6/12/2026</a:t>
             </a:fld>
             <a:endParaRPr lang="en-US"/>
           </a:p>
@@ -3115,7 +2923,7 @@
           <a:p>
             <a:fld id="{5BCAD085-E8A6-8845-BD4E-CB4CCA059FC4}" type="datetimeFigureOut">
               <a:rPr lang="en-US" smtClean="0"/>
-              <a:t>6/2/2026</a:t>
+              <a:t>6/12/2026</a:t>
             </a:fld>
             <a:endParaRPr lang="en-US"/>
           </a:p>
@@ -3326,7 +3134,7 @@
           <a:p>
             <a:fld id="{5BCAD085-E8A6-8845-BD4E-CB4CCA059FC4}" type="datetimeFigureOut">
               <a:rPr lang="en-US" smtClean="0"/>
-              <a:t>6/2/2026</a:t>
+              <a:t>6/12/2026</a:t>
             </a:fld>
             <a:endParaRPr lang="en-US"/>
           </a:p>
@@ -18274,305 +18082,20 @@
               </a:lnSpc>
             </a:pPr>
             <a:r>
-              <a:rPr sz="2800" b="1" i="0" dirty="0">
+              <a:rPr lang="en-US" sz="2800" b="1" i="0" dirty="0">
                 <a:solidFill>
                   <a:srgbClr val="1A1A2E"/>
                 </a:solidFill>
                 <a:latin typeface="Georgia"/>
               </a:rPr>
-              <a:t>Cuentas core y pipeline a </a:t>
-            </a:r>
-            <a:r>
-              <a:rPr lang="en-US" sz="2800" b="1" i="0" dirty="0" err="1">
-                <a:solidFill>
-                  <a:srgbClr val="1A1A2E"/>
-                </a:solidFill>
-                <a:latin typeface="Georgia"/>
-              </a:rPr>
-              <a:t>priorizar</a:t>
-            </a:r>
-            <a:r>
-              <a:rPr sz="2800" b="1" i="0" dirty="0">
-                <a:solidFill>
-                  <a:srgbClr val="1A1A2E"/>
-                </a:solidFill>
-                <a:latin typeface="Georgia"/>
-              </a:rPr>
-              <a:t> para FY27</a:t>
-            </a:r>
-          </a:p>
-        </p:txBody>
-      </p:sp>
-      <p:sp>
-        <p:nvSpPr>
-          <p:cNvPr id="6" name="TextBox 5"/>
-          <p:cNvSpPr txBox="1"/>
-          <p:nvPr/>
-        </p:nvSpPr>
-        <p:spPr>
-          <a:xfrm>
-            <a:off x="576072" y="1393065"/>
-            <a:ext cx="11064240" cy="548640"/>
-          </a:xfrm>
-          <a:prstGeom prst="rect">
-            <a:avLst/>
-          </a:prstGeom>
-          <a:noFill/>
-        </p:spPr>
-        <p:txBody>
-          <a:bodyPr wrap="square" lIns="0" tIns="25400" rIns="0" bIns="25400" anchor="t">
-            <a:spAutoFit/>
-          </a:bodyPr>
-          <a:lstStyle/>
-          <a:p>
-            <a:pPr algn="l">
-              <a:lnSpc>
-                <a:spcPct val="105000"/>
-              </a:lnSpc>
-            </a:pPr>
-            <a:r>
-              <a:rPr sz="1300" b="0" i="0" dirty="0">
-                <a:solidFill>
-                  <a:srgbClr val="4A4A5E"/>
-                </a:solidFill>
-                <a:latin typeface="Calibri"/>
-              </a:rPr>
-              <a:t>La </a:t>
-            </a:r>
-            <a:r>
-              <a:rPr sz="1300" b="0" i="0" dirty="0" err="1">
-                <a:solidFill>
-                  <a:srgbClr val="4A4A5E"/>
-                </a:solidFill>
-                <a:latin typeface="Calibri"/>
-              </a:rPr>
-              <a:t>estrategia</a:t>
-            </a:r>
-            <a:r>
-              <a:rPr sz="1300" b="0" i="0" dirty="0">
-                <a:solidFill>
-                  <a:srgbClr val="4A4A5E"/>
-                </a:solidFill>
-                <a:latin typeface="Calibri"/>
-              </a:rPr>
-              <a:t> FY27 </a:t>
-            </a:r>
-            <a:r>
-              <a:rPr sz="1300" b="0" i="0" dirty="0" err="1">
-                <a:solidFill>
-                  <a:srgbClr val="4A4A5E"/>
-                </a:solidFill>
-                <a:latin typeface="Calibri"/>
-              </a:rPr>
-              <a:t>ancla</a:t>
-            </a:r>
-            <a:r>
-              <a:rPr sz="1300" b="0" i="0" dirty="0">
-                <a:solidFill>
-                  <a:srgbClr val="4A4A5E"/>
-                </a:solidFill>
-                <a:latin typeface="Calibri"/>
-              </a:rPr>
-              <a:t> </a:t>
-            </a:r>
-            <a:r>
-              <a:rPr sz="1300" b="0" i="0" dirty="0" err="1">
-                <a:solidFill>
-                  <a:srgbClr val="4A4A5E"/>
-                </a:solidFill>
-                <a:latin typeface="Calibri"/>
-              </a:rPr>
-              <a:t>en</a:t>
-            </a:r>
-            <a:r>
-              <a:rPr sz="1300" b="0" i="0" dirty="0">
-                <a:solidFill>
-                  <a:srgbClr val="4A4A5E"/>
-                </a:solidFill>
-                <a:latin typeface="Calibri"/>
-              </a:rPr>
-              <a:t> las </a:t>
-            </a:r>
-            <a:r>
-              <a:rPr sz="1300" b="0" i="0" dirty="0" err="1">
-                <a:solidFill>
-                  <a:srgbClr val="4A4A5E"/>
-                </a:solidFill>
-                <a:latin typeface="Calibri"/>
-              </a:rPr>
-              <a:t>industrias</a:t>
-            </a:r>
-            <a:r>
-              <a:rPr sz="1300" b="0" i="0" dirty="0">
-                <a:solidFill>
-                  <a:srgbClr val="4A4A5E"/>
-                </a:solidFill>
-                <a:latin typeface="Calibri"/>
-              </a:rPr>
-              <a:t> </a:t>
-            </a:r>
-            <a:r>
-              <a:rPr sz="1300" b="0" i="0" dirty="0" err="1">
-                <a:solidFill>
-                  <a:srgbClr val="4A4A5E"/>
-                </a:solidFill>
-                <a:latin typeface="Calibri"/>
-              </a:rPr>
-              <a:t>prioritarias</a:t>
-            </a:r>
-            <a:r>
-              <a:rPr sz="1300" b="0" i="0" dirty="0">
-                <a:solidFill>
-                  <a:srgbClr val="4A4A5E"/>
-                </a:solidFill>
-                <a:latin typeface="Calibri"/>
-              </a:rPr>
-              <a:t> del offering y </a:t>
-            </a:r>
-            <a:r>
-              <a:rPr sz="1300" b="0" i="0" dirty="0" err="1">
-                <a:solidFill>
-                  <a:srgbClr val="4A4A5E"/>
-                </a:solidFill>
-                <a:latin typeface="Calibri"/>
-              </a:rPr>
-              <a:t>traslada</a:t>
-            </a:r>
-            <a:r>
-              <a:rPr sz="1300" b="0" i="0" dirty="0">
-                <a:solidFill>
-                  <a:srgbClr val="4A4A5E"/>
-                </a:solidFill>
-                <a:latin typeface="Calibri"/>
-              </a:rPr>
-              <a:t> </a:t>
-            </a:r>
-            <a:r>
-              <a:rPr sz="1300" b="0" i="0" dirty="0" err="1">
-                <a:solidFill>
-                  <a:srgbClr val="4A4A5E"/>
-                </a:solidFill>
-                <a:latin typeface="Calibri"/>
-              </a:rPr>
-              <a:t>el</a:t>
-            </a:r>
-            <a:r>
-              <a:rPr sz="1300" b="0" i="0" dirty="0">
-                <a:solidFill>
-                  <a:srgbClr val="4A4A5E"/>
-                </a:solidFill>
-                <a:latin typeface="Calibri"/>
-              </a:rPr>
-              <a:t> pipeline </a:t>
-            </a:r>
-            <a:r>
-              <a:rPr sz="1300" b="0" i="0" dirty="0" err="1">
-                <a:solidFill>
-                  <a:srgbClr val="4A4A5E"/>
-                </a:solidFill>
-                <a:latin typeface="Calibri"/>
-              </a:rPr>
-              <a:t>calificado</a:t>
-            </a:r>
-            <a:r>
-              <a:rPr sz="1300" b="0" i="0" dirty="0">
-                <a:solidFill>
-                  <a:srgbClr val="4A4A5E"/>
-                </a:solidFill>
-                <a:latin typeface="Calibri"/>
-              </a:rPr>
-              <a:t> </a:t>
-            </a:r>
-            <a:r>
-              <a:rPr sz="1300" b="0" i="0" dirty="0" err="1">
-                <a:solidFill>
-                  <a:srgbClr val="4A4A5E"/>
-                </a:solidFill>
-                <a:latin typeface="Calibri"/>
-              </a:rPr>
-              <a:t>como</a:t>
-            </a:r>
-            <a:r>
-              <a:rPr sz="1300" b="0" i="0" dirty="0">
-                <a:solidFill>
-                  <a:srgbClr val="4A4A5E"/>
-                </a:solidFill>
-                <a:latin typeface="Calibri"/>
-              </a:rPr>
-              <a:t> base. Los gaps </a:t>
-            </a:r>
-            <a:r>
-              <a:rPr sz="1300" b="0" i="0" dirty="0" err="1">
-                <a:solidFill>
-                  <a:srgbClr val="4A4A5E"/>
-                </a:solidFill>
-                <a:latin typeface="Calibri"/>
-              </a:rPr>
-              <a:t>por</a:t>
-            </a:r>
-            <a:r>
-              <a:rPr sz="1300" b="0" i="0" dirty="0">
-                <a:solidFill>
-                  <a:srgbClr val="4A4A5E"/>
-                </a:solidFill>
-                <a:latin typeface="Calibri"/>
-              </a:rPr>
-              <a:t> </a:t>
-            </a:r>
-            <a:r>
-              <a:rPr sz="1300" b="0" i="0" dirty="0" err="1">
-                <a:solidFill>
-                  <a:srgbClr val="4A4A5E"/>
-                </a:solidFill>
-                <a:latin typeface="Calibri"/>
-              </a:rPr>
-              <a:t>cuenta</a:t>
-            </a:r>
-            <a:r>
-              <a:rPr sz="1300" b="0" i="0" dirty="0">
-                <a:solidFill>
-                  <a:srgbClr val="4A4A5E"/>
-                </a:solidFill>
-                <a:latin typeface="Calibri"/>
-              </a:rPr>
-              <a:t> </a:t>
-            </a:r>
-            <a:r>
-              <a:rPr sz="1300" b="0" i="0" dirty="0" err="1">
-                <a:solidFill>
-                  <a:srgbClr val="4A4A5E"/>
-                </a:solidFill>
-                <a:latin typeface="Calibri"/>
-              </a:rPr>
-              <a:t>requieren</a:t>
-            </a:r>
-            <a:r>
-              <a:rPr sz="1300" b="0" i="0" dirty="0">
-                <a:solidFill>
-                  <a:srgbClr val="4A4A5E"/>
-                </a:solidFill>
-                <a:latin typeface="Calibri"/>
-              </a:rPr>
-              <a:t> </a:t>
-            </a:r>
-            <a:r>
-              <a:rPr sz="1300" b="0" i="0" dirty="0" err="1">
-                <a:solidFill>
-                  <a:srgbClr val="4A4A5E"/>
-                </a:solidFill>
-                <a:latin typeface="Calibri"/>
-              </a:rPr>
-              <a:t>consolidación</a:t>
-            </a:r>
-            <a:r>
-              <a:rPr sz="1300" b="0" i="0" dirty="0">
-                <a:solidFill>
-                  <a:srgbClr val="4A4A5E"/>
-                </a:solidFill>
-                <a:latin typeface="Calibri"/>
-              </a:rPr>
-              <a:t>.</a:t>
-            </a:r>
+              <a:t>Pipeline actual FY26 /FY27</a:t>
+            </a:r>
+            <a:endParaRPr sz="2800" b="1" i="0" dirty="0">
+              <a:solidFill>
+                <a:srgbClr val="1A1A2E"/>
+              </a:solidFill>
+              <a:latin typeface="Georgia"/>
+            </a:endParaRPr>
           </a:p>
         </p:txBody>
       </p:sp>
@@ -18669,14 +18192,14 @@
           <p:nvPr>
             <p:extLst>
               <p:ext uri="{D42A27DB-BD31-4B8C-83A1-F6EECF244321}">
-                <p14:modId xmlns:p14="http://schemas.microsoft.com/office/powerpoint/2010/main" val="359302464"/>
+                <p14:modId xmlns:p14="http://schemas.microsoft.com/office/powerpoint/2010/main" val="1708728381"/>
               </p:ext>
             </p:extLst>
           </p:nvPr>
         </p:nvGraphicFramePr>
         <p:xfrm>
-          <a:off x="749808" y="1734311"/>
-          <a:ext cx="10080948" cy="4663440"/>
+          <a:off x="749807" y="1405427"/>
+          <a:ext cx="10714311" cy="4922520"/>
         </p:xfrm>
         <a:graphic>
           <a:graphicData uri="http://schemas.openxmlformats.org/drawingml/2006/table">
@@ -18685,28 +18208,28 @@
                 <a:tableStyleId>{17292A2E-F333-43FB-9621-5CBBE7FDCDCB}</a:tableStyleId>
               </a:tblPr>
               <a:tblGrid>
-                <a:gridCol w="2520237">
+                <a:gridCol w="2678578">
                   <a:extLst>
                     <a:ext uri="{9D8B030D-6E8A-4147-A177-3AD203B41FA5}">
                       <a16:colId xmlns:a16="http://schemas.microsoft.com/office/drawing/2014/main" val="354519814"/>
                     </a:ext>
                   </a:extLst>
                 </a:gridCol>
-                <a:gridCol w="2520237">
+                <a:gridCol w="2678578">
                   <a:extLst>
                     <a:ext uri="{9D8B030D-6E8A-4147-A177-3AD203B41FA5}">
                       <a16:colId xmlns:a16="http://schemas.microsoft.com/office/drawing/2014/main" val="1274239331"/>
                     </a:ext>
                   </a:extLst>
                 </a:gridCol>
-                <a:gridCol w="2581362">
+                <a:gridCol w="2743543">
                   <a:extLst>
                     <a:ext uri="{9D8B030D-6E8A-4147-A177-3AD203B41FA5}">
                       <a16:colId xmlns:a16="http://schemas.microsoft.com/office/drawing/2014/main" val="952470766"/>
                     </a:ext>
                   </a:extLst>
                 </a:gridCol>
-                <a:gridCol w="2459112">
+                <a:gridCol w="2613612">
                   <a:extLst>
                     <a:ext uri="{9D8B030D-6E8A-4147-A177-3AD203B41FA5}">
                       <a16:colId xmlns:a16="http://schemas.microsoft.com/office/drawing/2014/main" val="397920090"/>
@@ -18714,7 +18237,7 @@
                   </a:extLst>
                 </a:gridCol>
               </a:tblGrid>
-              <a:tr h="125873">
+              <a:tr h="213545">
                 <a:tc>
                   <a:txBody>
                     <a:bodyPr/>
@@ -18789,7 +18312,7 @@
                   </a:ext>
                 </a:extLst>
               </a:tr>
-              <a:tr h="125873">
+              <a:tr h="213545">
                 <a:tc>
                   <a:txBody>
                     <a:bodyPr/>
@@ -18852,7 +18375,7 @@
                   </a:ext>
                 </a:extLst>
               </a:tr>
-              <a:tr h="125873">
+              <a:tr h="213545">
                 <a:tc>
                   <a:txBody>
                     <a:bodyPr/>
@@ -18932,7 +18455,7 @@
                   </a:ext>
                 </a:extLst>
               </a:tr>
-              <a:tr h="125873">
+              <a:tr h="213545">
                 <a:tc>
                   <a:txBody>
                     <a:bodyPr/>
@@ -18991,7 +18514,7 @@
                   </a:ext>
                 </a:extLst>
               </a:tr>
-              <a:tr h="125873">
+              <a:tr h="213545">
                 <a:tc>
                   <a:txBody>
                     <a:bodyPr/>
@@ -19050,7 +18573,7 @@
                   </a:ext>
                 </a:extLst>
               </a:tr>
-              <a:tr h="125873">
+              <a:tr h="213545">
                 <a:tc>
                   <a:txBody>
                     <a:bodyPr/>
@@ -19109,7 +18632,7 @@
                   </a:ext>
                 </a:extLst>
               </a:tr>
-              <a:tr h="125873">
+              <a:tr h="213545">
                 <a:tc>
                   <a:txBody>
                     <a:bodyPr/>
@@ -19168,7 +18691,7 @@
                   </a:ext>
                 </a:extLst>
               </a:tr>
-              <a:tr h="125873">
+              <a:tr h="213545">
                 <a:tc>
                   <a:txBody>
                     <a:bodyPr/>
@@ -19227,7 +18750,7 @@
                   </a:ext>
                 </a:extLst>
               </a:tr>
-              <a:tr h="125873">
+              <a:tr h="213545">
                 <a:tc>
                   <a:txBody>
                     <a:bodyPr/>
@@ -19286,7 +18809,7 @@
                   </a:ext>
                 </a:extLst>
               </a:tr>
-              <a:tr h="125873">
+              <a:tr h="213545">
                 <a:tc>
                   <a:txBody>
                     <a:bodyPr/>
@@ -19345,7 +18868,7 @@
                   </a:ext>
                 </a:extLst>
               </a:tr>
-              <a:tr h="125873">
+              <a:tr h="213545">
                 <a:tc>
                   <a:txBody>
                     <a:bodyPr/>
@@ -19409,7 +18932,7 @@
                   </a:ext>
                 </a:extLst>
               </a:tr>
-              <a:tr h="125873">
+              <a:tr h="213545">
                 <a:tc>
                   <a:txBody>
                     <a:bodyPr/>
@@ -19468,7 +18991,7 @@
                   </a:ext>
                 </a:extLst>
               </a:tr>
-              <a:tr h="125873">
+              <a:tr h="213545">
                 <a:tc>
                   <a:txBody>
                     <a:bodyPr/>
@@ -19527,7 +19050,7 @@
                   </a:ext>
                 </a:extLst>
               </a:tr>
-              <a:tr h="125873">
+              <a:tr h="213545">
                 <a:tc>
                   <a:txBody>
                     <a:bodyPr/>
@@ -19574,7 +19097,7 @@
                   </a:ext>
                 </a:extLst>
               </a:tr>
-              <a:tr h="125873">
+              <a:tr h="213545">
                 <a:tc>
                   <a:txBody>
                     <a:bodyPr/>
@@ -19634,7 +19157,7 @@
                   </a:ext>
                 </a:extLst>
               </a:tr>
-              <a:tr h="125873">
+              <a:tr h="213545">
                 <a:tc>
                   <a:txBody>
                     <a:bodyPr/>
@@ -19693,7 +19216,7 @@
                   </a:ext>
                 </a:extLst>
               </a:tr>
-              <a:tr h="125873">
+              <a:tr h="213545">
                 <a:tc>
                   <a:txBody>
                     <a:bodyPr/>
@@ -19752,7 +19275,7 @@
                   </a:ext>
                 </a:extLst>
               </a:tr>
-              <a:tr h="125873">
+              <a:tr h="213545">
                 <a:tc>
                   <a:txBody>
                     <a:bodyPr/>
@@ -19808,6 +19331,66 @@
                 <a:extLst>
                   <a:ext uri="{0D108BD9-81ED-4DB2-BD59-A6C34878D82A}">
                     <a16:rowId xmlns:a16="http://schemas.microsoft.com/office/drawing/2014/main" val="2692870434"/>
+                  </a:ext>
+                </a:extLst>
+              </a:tr>
+              <a:tr h="213545">
+                <a:tc>
+                  <a:txBody>
+                    <a:bodyPr/>
+                    <a:lstStyle/>
+                    <a:p>
+                      <a:r>
+                        <a:rPr lang="en-US" sz="1100" dirty="0" err="1"/>
+                        <a:t>Innovasport</a:t>
+                      </a:r>
+                      <a:endParaRPr lang="en-US" sz="1100" dirty="0"/>
+                    </a:p>
+                  </a:txBody>
+                  <a:tcPr/>
+                </a:tc>
+                <a:tc>
+                  <a:txBody>
+                    <a:bodyPr/>
+                    <a:lstStyle/>
+                    <a:p>
+                      <a:r>
+                        <a:rPr lang="en-US" sz="1100" dirty="0"/>
+                        <a:t>Data Migration a Snowflake</a:t>
+                      </a:r>
+                    </a:p>
+                  </a:txBody>
+                  <a:tcPr/>
+                </a:tc>
+                <a:tc>
+                  <a:txBody>
+                    <a:bodyPr/>
+                    <a:lstStyle/>
+                    <a:p>
+                      <a:r>
+                        <a:rPr lang="en-US" sz="1100" dirty="0"/>
+                        <a:t>No</a:t>
+                      </a:r>
+                    </a:p>
+                  </a:txBody>
+                  <a:tcPr/>
+                </a:tc>
+                <a:tc>
+                  <a:txBody>
+                    <a:bodyPr/>
+                    <a:lstStyle/>
+                    <a:p>
+                      <a:r>
+                        <a:rPr lang="en-US" sz="1100" dirty="0"/>
+                        <a:t>1.2 MDD</a:t>
+                      </a:r>
+                    </a:p>
+                  </a:txBody>
+                  <a:tcPr/>
+                </a:tc>
+                <a:extLst>
+                  <a:ext uri="{0D108BD9-81ED-4DB2-BD59-A6C34878D82A}">
+                    <a16:rowId xmlns:a16="http://schemas.microsoft.com/office/drawing/2014/main" val="2085868043"/>
                   </a:ext>
                 </a:extLst>
               </a:tr>

</xml_diff>